<commit_message>
Refactor documentation, presentation, and reports into professional academic format
</commit_message>
<xml_diff>
--- a/presentation/OpenMP_vs_MPI_Data_Processing.pptx
+++ b/presentation/OpenMP_vs_MPI_Data_Processing.pptx
@@ -3265,11 +3265,15 @@
               </a:defRPr>
             </a:pPr>
             <a:r>
-              <a:t>Theme: OpenMP vs MPI Data Processing  |  Model: OpenMP + MPI</a:t>
+              <a:t>Author: Vinay Hiremath</a:t>
             </a:r>
             <a:br/>
             <a:r>
-              <a:t>Checkpoint 1 - 5 Implementation  |  Academic Year 2026-2027</a:t>
+              <a:t>Domain: Parallel &amp; Distributed Computing</a:t>
+            </a:r>
+            <a:br/>
+            <a:r>
+              <a:t>Theme: OpenMP vs MPI for Data Processing</a:t>
             </a:r>
           </a:p>
         </p:txBody>
@@ -4872,7 +4876,7 @@
               </a:defRPr>
             </a:pPr>
             <a:r>
-              <a:t>11. Technical Viva Questions &amp; Detailed Answers</a:t>
+              <a:t>11. Architectural Discussion &amp; Scalability Insights</a:t>
             </a:r>
           </a:p>
         </p:txBody>
@@ -4955,7 +4959,7 @@
               </a:defRPr>
             </a:pPr>
             <a:r>
-              <a:t>Q1: Why did Pass 2 require MPI_Bcast in MPI but nothing in OpenMP?</a:t>
+              <a:t>Shared vs. Distributed Memory Trade-offs</a:t>
             </a:r>
           </a:p>
           <a:p>
@@ -4970,7 +4974,7 @@
               </a:defRPr>
             </a:pPr>
             <a:r>
-              <a:t>In OpenMP, global mean is stored in shared RAM, so all threads read it directly. In MPI, each process has an isolated memory space; rank 0 must explicitly broadcast the mean to other ranks.</a:t>
+              <a:t>OpenMP excels on single-node SMP systems with zero message serialization overhead. MPI provides superior cache isolation through 1D domain decomposition.</a:t>
             </a:r>
           </a:p>
           <a:p>
@@ -4985,7 +4989,7 @@
               </a:defRPr>
             </a:pPr>
             <a:r>
-              <a:t>Q2: Why does speedup saturate beyond 8 cores on this machine?</a:t>
+              <a:t>Collective Communication Latency</a:t>
             </a:r>
           </a:p>
           <a:p>
@@ -5000,7 +5004,7 @@
               </a:defRPr>
             </a:pPr>
             <a:r>
-              <a:t>The Intel i5-13420H has 8 physical cores and 4 efficiency/SMT hyperthreads. Additionally, data processing is memory-bandwidth bound; RAM bus saturation limits further scaling.</a:t>
+              <a:t>MPI requires explicit synchronization (MPI_Bcast, MPI_Reduce) using binomial spanning trees with O(log P) complexity to distribute and reduce variables.</a:t>
             </a:r>
           </a:p>
           <a:p>
@@ -5015,7 +5019,7 @@
               </a:defRPr>
             </a:pPr>
             <a:r>
-              <a:t>Q3: How does OpenMP handle race conditions during reduction?</a:t>
+              <a:t>Memory Bus &amp; Roofline Limits</a:t>
             </a:r>
           </a:p>
           <a:p>
@@ -5030,7 +5034,7 @@
               </a:defRPr>
             </a:pPr>
             <a:r>
-              <a:t>The reduction clause generates private accumulator variables for each thread. At the end of the parallel region, OpenMP combines private values into the shared variable using atomic hardware operations.</a:t>
+              <a:t>Speedup saturation beyond 8 cores is governed by memory bandwidth limits on the host memory controller when processing contiguous floating-point streams.</a:t>
             </a:r>
           </a:p>
           <a:p>
@@ -5045,7 +5049,7 @@
               </a:defRPr>
             </a:pPr>
             <a:r>
-              <a:t>Q4: What is the communication complexity of MPI_Reduce and MPI_Bcast?</a:t>
+              <a:t>Heterogeneous Core Scaling</a:t>
             </a:r>
           </a:p>
           <a:p>
@@ -5060,7 +5064,7 @@
               </a:defRPr>
             </a:pPr>
             <a:r>
-              <a:t>Both use binomial or butterfly tree algorithms with O(log P) communication steps, avoiding an O(P) bottleneck at rank 0.</a:t>
+              <a:t>Intel hybrid architectures (P-cores vs E-cores) and hyperthreading (SMT) deliver diminishing efficiency returns compared to dedicated physical execution units.</a:t>
             </a:r>
           </a:p>
         </p:txBody>
@@ -5530,7 +5534,7 @@
               </a:defRPr>
             </a:pPr>
             <a:r>
-              <a:t>1. Project Objectives &amp; Evaluation Checkpoints</a:t>
+              <a:t>1. Project Motivation &amp; Research Objectives</a:t>
             </a:r>
           </a:p>
         </p:txBody>
@@ -5613,7 +5617,7 @@
               </a:defRPr>
             </a:pPr>
             <a:r>
-              <a:t>Core Task (Topic 9)</a:t>
+              <a:t>Core Objective</a:t>
             </a:r>
           </a:p>
           <a:p>
@@ -5628,7 +5632,7 @@
               </a:defRPr>
             </a:pPr>
             <a:r>
-              <a:t>Perform identical numerical dataset operation using OpenMP and MPI, benchmarking runtime, speedup, and scalability.</a:t>
+              <a:t>Implement identical numerical dataset operations in OpenMP and MPI to quantitatively evaluate latency, speedup, and scalability.</a:t>
             </a:r>
           </a:p>
           <a:p>
@@ -5643,7 +5647,7 @@
               </a:defRPr>
             </a:pPr>
             <a:r>
-              <a:t>Checkpoint 1: Problem Definition &amp; Sequential Algorithm (2 Marks)</a:t>
+              <a:t>Multi-Paradigm Study</a:t>
             </a:r>
           </a:p>
           <a:p>
@@ -5658,7 +5662,7 @@
               </a:defRPr>
             </a:pPr>
             <a:r>
-              <a:t>Formal mathematical modeling of dataset operations (Reductions + Conditional Filtering) and sequential baseline.</a:t>
+              <a:t>Benchmarking shared-memory thread parallelism (OpenMP) against distributed-memory message passing (MPI) with zero computational drift.</a:t>
             </a:r>
           </a:p>
           <a:p>
@@ -5673,7 +5677,7 @@
               </a:defRPr>
             </a:pPr>
             <a:r>
-              <a:t>Checkpoint 2: Working Parallel Implementation (2 Marks)</a:t>
+              <a:t>Multi-Scale Experimental Grid</a:t>
             </a:r>
           </a:p>
           <a:p>
@@ -5688,7 +5692,7 @@
               </a:defRPr>
             </a:pPr>
             <a:r>
-              <a:t>Implementation using OpenMP multithreading (shared memory) and MS-MPI message passing (distributed memory).</a:t>
+              <a:t>Systematic evaluation across dataset sizes (5M to 50M doubles) and worker counts (1 to 12 threads/processes).</a:t>
             </a:r>
           </a:p>
           <a:p>
@@ -5703,7 +5707,7 @@
               </a:defRPr>
             </a:pPr>
             <a:r>
-              <a:t>Checkpoint 3: Empirical Benchmarking Across Scales (2 Marks)</a:t>
+              <a:t>Architectural Analysis</a:t>
             </a:r>
           </a:p>
           <a:p>
@@ -5718,7 +5722,7 @@
               </a:defRPr>
             </a:pPr>
             <a:r>
-              <a:t>Systematic testing across dataset sizes (5M to 50M) and worker counts (1 to 12 threads/processes) with 3 repetitions.</a:t>
+              <a:t>Evaluating Amdahl's Law, parallel efficiency decay, memory bus contention, and collective communication overhead.</a:t>
             </a:r>
           </a:p>
           <a:p>
@@ -5733,7 +5737,7 @@
               </a:defRPr>
             </a:pPr>
             <a:r>
-              <a:t>Checkpoint 4: Visualization &amp; Performance Analysis (2 Marks)</a:t>
+              <a:t>Performance Metrics</a:t>
             </a:r>
           </a:p>
           <a:p>
@@ -5748,37 +5752,7 @@
               </a:defRPr>
             </a:pPr>
             <a:r>
-              <a:t>Speedup curves, Amdahl's Law validation, and parallel efficiency profiling with high-resolution plots.</a:t>
-            </a:r>
-          </a:p>
-          <a:p>
-            <a:pPr>
-              <a:spcAft>
-                <a:spcPts val="200"/>
-              </a:spcAft>
-              <a:defRPr sz="1300" b="1">
-                <a:solidFill>
-                  <a:srgbClr val="182B49"/>
-                </a:solidFill>
-              </a:defRPr>
-            </a:pPr>
-            <a:r>
-              <a:t>Checkpoint 5: Technical Viva &amp; Verification (2 Marks)</a:t>
-            </a:r>
-          </a:p>
-          <a:p>
-            <a:pPr>
-              <a:spcAft>
-                <a:spcPts val="1000"/>
-              </a:spcAft>
-              <a:defRPr sz="1100">
-                <a:solidFill>
-                  <a:srgbClr val="2D3436"/>
-                </a:solidFill>
-              </a:defRPr>
-            </a:pPr>
-            <a:r>
-              <a:t>Complete conceptual and architectural readiness for guide questions and live demonstration.</a:t>
+              <a:t>Measuring wall-clock time (ms), speedup factor S, parallel efficiency E (%), and processing throughput (Million items/sec).</a:t>
             </a:r>
           </a:p>
         </p:txBody>

</xml_diff>

<commit_message>
Update student details: Vinay V Hiremath (01FE24BCI069)
</commit_message>
<xml_diff>
--- a/presentation/OpenMP_vs_MPI_Data_Processing.pptx
+++ b/presentation/OpenMP_vs_MPI_Data_Processing.pptx
@@ -3265,15 +3265,15 @@
               </a:defRPr>
             </a:pPr>
             <a:r>
-              <a:t>Author: Vinay Hiremath</a:t>
+              <a:t>Author: Vinay V Hiremath (USN: 01FE24BCI069)</a:t>
             </a:r>
             <a:br/>
             <a:r>
-              <a:t>Domain: Parallel &amp; Distributed Computing</a:t>
+              <a:t>Department: Computer Science &amp; Engineering [AI]</a:t>
             </a:r>
             <a:br/>
             <a:r>
-              <a:t>Theme: OpenMP vs MPI for Data Processing</a:t>
+              <a:t>Topic: OpenMP vs MPI for Data Processing</a:t>
             </a:r>
           </a:p>
         </p:txBody>

</xml_diff>

<commit_message>
Add terminal execution screenshots and embed them into README, PPTX, and PDF report
</commit_message>
<xml_diff>
--- a/presentation/OpenMP_vs_MPI_Data_Processing.pptx
+++ b/presentation/OpenMP_vs_MPI_Data_Processing.pptx
@@ -18,6 +18,7 @@
     <p:sldId id="266" r:id="rId17"/>
     <p:sldId id="267" r:id="rId18"/>
     <p:sldId id="268" r:id="rId19"/>
+    <p:sldId id="269" r:id="rId20"/>
   </p:sldIdLst>
   <p:sldSz cx="9144000" cy="5143500" type="screen4x3"/>
   <p:notesSz cx="6858000" cy="9144000"/>
@@ -3767,7 +3768,330 @@
               </a:defRPr>
             </a:pPr>
             <a:r>
-              <a:t>10. Comprehensive Comparison: OpenMP vs MPI</a:t>
+              <a:t>10. Program Execution &amp; Verification</a:t>
+            </a:r>
+          </a:p>
+        </p:txBody>
+      </p:sp>
+      <p:pic>
+        <p:nvPicPr>
+          <p:cNvPr id="5" name="Picture 4" descr="03_execution_verification.png"/>
+          <p:cNvPicPr>
+            <a:picLocks noChangeAspect="1"/>
+          </p:cNvPicPr>
+          <p:nvPr/>
+        </p:nvPicPr>
+        <p:blipFill>
+          <a:blip r:embed="rId2"/>
+          <a:stretch>
+            <a:fillRect/>
+          </a:stretch>
+        </p:blipFill>
+        <p:spPr>
+          <a:xfrm>
+            <a:off x="731520" y="1188720"/>
+            <a:ext cx="4572000" cy="3474720"/>
+          </a:xfrm>
+          <a:prstGeom prst="rect">
+            <a:avLst/>
+          </a:prstGeom>
+        </p:spPr>
+      </p:pic>
+      <p:sp>
+        <p:nvSpPr>
+          <p:cNvPr id="6" name="Rounded Rectangle 5"/>
+          <p:cNvSpPr/>
+          <p:nvPr/>
+        </p:nvSpPr>
+        <p:spPr>
+          <a:xfrm>
+            <a:off x="5486400" y="1188720"/>
+            <a:ext cx="2926080" cy="3474720"/>
+          </a:xfrm>
+          <a:prstGeom prst="roundRect">
+            <a:avLst/>
+          </a:prstGeom>
+          <a:solidFill>
+            <a:srgbClr val="FFFFFF"/>
+          </a:solidFill>
+          <a:ln>
+            <a:solidFill>
+              <a:srgbClr val="DCE0E6"/>
+            </a:solidFill>
+          </a:ln>
+        </p:spPr>
+        <p:style>
+          <a:lnRef idx="1">
+            <a:schemeClr val="accent1"/>
+          </a:lnRef>
+          <a:fillRef idx="3">
+            <a:schemeClr val="accent1"/>
+          </a:fillRef>
+          <a:effectRef idx="2">
+            <a:schemeClr val="accent1"/>
+          </a:effectRef>
+          <a:fontRef idx="minor">
+            <a:schemeClr val="lt1"/>
+          </a:fontRef>
+        </p:style>
+        <p:txBody>
+          <a:bodyPr rtlCol="0" anchor="ctr"/>
+          <a:lstStyle/>
+          <a:p>
+            <a:pPr algn="ctr"/>
+          </a:p>
+        </p:txBody>
+      </p:sp>
+      <p:sp>
+        <p:nvSpPr>
+          <p:cNvPr id="7" name="TextBox 6"/>
+          <p:cNvSpPr txBox="1"/>
+          <p:nvPr/>
+        </p:nvSpPr>
+        <p:spPr>
+          <a:xfrm>
+            <a:off x="5623560" y="1325880"/>
+            <a:ext cx="2651760" cy="3200400"/>
+          </a:xfrm>
+          <a:prstGeom prst="rect">
+            <a:avLst/>
+          </a:prstGeom>
+          <a:noFill/>
+        </p:spPr>
+        <p:txBody>
+          <a:bodyPr wrap="square">
+            <a:spAutoFit/>
+          </a:bodyPr>
+          <a:lstStyle/>
+          <a:p>
+            <a:pPr>
+              <a:spcAft>
+                <a:spcPts val="200"/>
+              </a:spcAft>
+              <a:defRPr sz="1100" b="1">
+                <a:solidFill>
+                  <a:srgbClr val="182B49"/>
+                </a:solidFill>
+              </a:defRPr>
+            </a:pPr>
+            <a:r>
+              <a:t>Identical Numerical Outputs</a:t>
+            </a:r>
+          </a:p>
+          <a:p>
+            <a:pPr>
+              <a:spcAft>
+                <a:spcPts val="800"/>
+              </a:spcAft>
+              <a:defRPr sz="950">
+                <a:solidFill>
+                  <a:srgbClr val="2D3436"/>
+                </a:solidFill>
+              </a:defRPr>
+            </a:pPr>
+            <a:r>
+              <a:t>All three models (Sequential, OpenMP, MPI) produce bitwise identical Sum, Mean, Min, Max, and Count &gt; Mean.</a:t>
+            </a:r>
+          </a:p>
+          <a:p>
+            <a:pPr>
+              <a:spcAft>
+                <a:spcPts val="200"/>
+              </a:spcAft>
+              <a:defRPr sz="1100" b="1">
+                <a:solidFill>
+                  <a:srgbClr val="182B49"/>
+                </a:solidFill>
+              </a:defRPr>
+            </a:pPr>
+            <a:r>
+              <a:t>Latency Reductions (10M)</a:t>
+            </a:r>
+          </a:p>
+          <a:p>
+            <a:pPr>
+              <a:spcAft>
+                <a:spcPts val="800"/>
+              </a:spcAft>
+              <a:defRPr sz="950">
+                <a:solidFill>
+                  <a:srgbClr val="2D3436"/>
+                </a:solidFill>
+              </a:defRPr>
+            </a:pPr>
+            <a:r>
+              <a:t>Execution latency reduced from 15.69 ms (Sequential) to 6.77 ms (OpenMP 4T) and 6.98 ms (MPI 4P).</a:t>
+            </a:r>
+          </a:p>
+          <a:p>
+            <a:pPr>
+              <a:spcAft>
+                <a:spcPts val="200"/>
+              </a:spcAft>
+              <a:defRPr sz="1100" b="1">
+                <a:solidFill>
+                  <a:srgbClr val="182B49"/>
+                </a:solidFill>
+              </a:defRPr>
+            </a:pPr>
+            <a:r>
+              <a:t>Student Identity Verification</a:t>
+            </a:r>
+          </a:p>
+          <a:p>
+            <a:pPr>
+              <a:spcAft>
+                <a:spcPts val="800"/>
+              </a:spcAft>
+              <a:defRPr sz="950">
+                <a:solidFill>
+                  <a:srgbClr val="2D3436"/>
+                </a:solidFill>
+              </a:defRPr>
+            </a:pPr>
+            <a:r>
+              <a:t>Active terminal outputs demonstrate runs attributed to Vinay V Hiremath (USN: 01FE24BCI069).</a:t>
+            </a:r>
+          </a:p>
+        </p:txBody>
+      </p:sp>
+    </p:spTree>
+  </p:cSld>
+  <p:clrMapOvr>
+    <a:masterClrMapping/>
+  </p:clrMapOvr>
+</p:sld>
+</file>
+
+<file path=ppt/slides/slide12.xml><?xml version="1.0" encoding="utf-8"?>
+<p:sld xmlns:a="http://schemas.openxmlformats.org/drawingml/2006/main" xmlns:p="http://schemas.openxmlformats.org/presentationml/2006/main" xmlns:r="http://schemas.openxmlformats.org/officeDocument/2006/relationships">
+  <p:cSld>
+    <p:bg>
+      <p:bgPr>
+        <a:solidFill>
+          <a:srgbClr val="F5F7FA"/>
+        </a:solidFill>
+        <a:effectLst/>
+      </p:bgPr>
+    </p:bg>
+    <p:spTree>
+      <p:nvGrpSpPr>
+        <p:cNvPr id="1" name=""/>
+        <p:cNvGrpSpPr/>
+        <p:nvPr/>
+      </p:nvGrpSpPr>
+      <p:grpSpPr/>
+      <p:sp>
+        <p:nvSpPr>
+          <p:cNvPr id="2" name="Rectangle 1"/>
+          <p:cNvSpPr/>
+          <p:nvPr/>
+        </p:nvSpPr>
+        <p:spPr>
+          <a:xfrm>
+            <a:off x="0" y="0"/>
+            <a:ext cx="9144000" cy="1005840"/>
+          </a:xfrm>
+          <a:prstGeom prst="rect">
+            <a:avLst/>
+          </a:prstGeom>
+          <a:solidFill>
+            <a:srgbClr val="182B49"/>
+          </a:solidFill>
+          <a:ln>
+            <a:solidFill>
+              <a:srgbClr val="182B49"/>
+            </a:solidFill>
+          </a:ln>
+        </p:spPr>
+        <p:style>
+          <a:lnRef idx="1">
+            <a:schemeClr val="accent1"/>
+          </a:lnRef>
+          <a:fillRef idx="3">
+            <a:schemeClr val="accent1"/>
+          </a:fillRef>
+          <a:effectRef idx="2">
+            <a:schemeClr val="accent1"/>
+          </a:effectRef>
+          <a:fontRef idx="minor">
+            <a:schemeClr val="lt1"/>
+          </a:fontRef>
+        </p:style>
+        <p:txBody>
+          <a:bodyPr rtlCol="0" anchor="ctr"/>
+          <a:lstStyle/>
+          <a:p>
+            <a:pPr algn="ctr"/>
+          </a:p>
+        </p:txBody>
+      </p:sp>
+      <p:sp>
+        <p:nvSpPr>
+          <p:cNvPr id="3" name="TextBox 2"/>
+          <p:cNvSpPr txBox="1"/>
+          <p:nvPr/>
+        </p:nvSpPr>
+        <p:spPr>
+          <a:xfrm>
+            <a:off x="731520" y="109728"/>
+            <a:ext cx="7680960" cy="274320"/>
+          </a:xfrm>
+          <a:prstGeom prst="rect">
+            <a:avLst/>
+          </a:prstGeom>
+          <a:noFill/>
+        </p:spPr>
+        <p:txBody>
+          <a:bodyPr wrap="square">
+            <a:spAutoFit/>
+          </a:bodyPr>
+          <a:lstStyle/>
+          <a:p>
+            <a:pPr>
+              <a:defRPr sz="1000" b="1">
+                <a:solidFill>
+                  <a:srgbClr val="107C82"/>
+                </a:solidFill>
+              </a:defRPr>
+            </a:pPr>
+            <a:r>
+              <a:t>PARALLEL COMPUTING MINI-PROJECT | TOPIC #9</a:t>
+            </a:r>
+          </a:p>
+        </p:txBody>
+      </p:sp>
+      <p:sp>
+        <p:nvSpPr>
+          <p:cNvPr id="4" name="TextBox 3"/>
+          <p:cNvSpPr txBox="1"/>
+          <p:nvPr/>
+        </p:nvSpPr>
+        <p:spPr>
+          <a:xfrm>
+            <a:off x="731520" y="384048"/>
+            <a:ext cx="7680960" cy="502920"/>
+          </a:xfrm>
+          <a:prstGeom prst="rect">
+            <a:avLst/>
+          </a:prstGeom>
+          <a:noFill/>
+        </p:spPr>
+        <p:txBody>
+          <a:bodyPr wrap="square">
+            <a:spAutoFit/>
+          </a:bodyPr>
+          <a:lstStyle/>
+          <a:p>
+            <a:pPr>
+              <a:defRPr sz="2000" b="1">
+                <a:solidFill>
+                  <a:srgbClr val="FFFFFF"/>
+                </a:solidFill>
+              </a:defRPr>
+            </a:pPr>
+            <a:r>
+              <a:t>11. Comprehensive Comparison: OpenMP vs MPI</a:t>
             </a:r>
           </a:p>
         </p:txBody>
@@ -4748,335 +5072,6 @@
 </p:sld>
 </file>
 
-<file path=ppt/slides/slide12.xml><?xml version="1.0" encoding="utf-8"?>
-<p:sld xmlns:a="http://schemas.openxmlformats.org/drawingml/2006/main" xmlns:p="http://schemas.openxmlformats.org/presentationml/2006/main" xmlns:r="http://schemas.openxmlformats.org/officeDocument/2006/relationships">
-  <p:cSld>
-    <p:bg>
-      <p:bgPr>
-        <a:solidFill>
-          <a:srgbClr val="F5F7FA"/>
-        </a:solidFill>
-        <a:effectLst/>
-      </p:bgPr>
-    </p:bg>
-    <p:spTree>
-      <p:nvGrpSpPr>
-        <p:cNvPr id="1" name=""/>
-        <p:cNvGrpSpPr/>
-        <p:nvPr/>
-      </p:nvGrpSpPr>
-      <p:grpSpPr/>
-      <p:sp>
-        <p:nvSpPr>
-          <p:cNvPr id="2" name="Rectangle 1"/>
-          <p:cNvSpPr/>
-          <p:nvPr/>
-        </p:nvSpPr>
-        <p:spPr>
-          <a:xfrm>
-            <a:off x="0" y="0"/>
-            <a:ext cx="9144000" cy="1005840"/>
-          </a:xfrm>
-          <a:prstGeom prst="rect">
-            <a:avLst/>
-          </a:prstGeom>
-          <a:solidFill>
-            <a:srgbClr val="182B49"/>
-          </a:solidFill>
-          <a:ln>
-            <a:solidFill>
-              <a:srgbClr val="182B49"/>
-            </a:solidFill>
-          </a:ln>
-        </p:spPr>
-        <p:style>
-          <a:lnRef idx="1">
-            <a:schemeClr val="accent1"/>
-          </a:lnRef>
-          <a:fillRef idx="3">
-            <a:schemeClr val="accent1"/>
-          </a:fillRef>
-          <a:effectRef idx="2">
-            <a:schemeClr val="accent1"/>
-          </a:effectRef>
-          <a:fontRef idx="minor">
-            <a:schemeClr val="lt1"/>
-          </a:fontRef>
-        </p:style>
-        <p:txBody>
-          <a:bodyPr rtlCol="0" anchor="ctr"/>
-          <a:lstStyle/>
-          <a:p>
-            <a:pPr algn="ctr"/>
-          </a:p>
-        </p:txBody>
-      </p:sp>
-      <p:sp>
-        <p:nvSpPr>
-          <p:cNvPr id="3" name="TextBox 2"/>
-          <p:cNvSpPr txBox="1"/>
-          <p:nvPr/>
-        </p:nvSpPr>
-        <p:spPr>
-          <a:xfrm>
-            <a:off x="731520" y="109728"/>
-            <a:ext cx="7680960" cy="274320"/>
-          </a:xfrm>
-          <a:prstGeom prst="rect">
-            <a:avLst/>
-          </a:prstGeom>
-          <a:noFill/>
-        </p:spPr>
-        <p:txBody>
-          <a:bodyPr wrap="square">
-            <a:spAutoFit/>
-          </a:bodyPr>
-          <a:lstStyle/>
-          <a:p>
-            <a:pPr>
-              <a:defRPr sz="1000" b="1">
-                <a:solidFill>
-                  <a:srgbClr val="107C82"/>
-                </a:solidFill>
-              </a:defRPr>
-            </a:pPr>
-            <a:r>
-              <a:t>PARALLEL COMPUTING MINI-PROJECT | TOPIC #9</a:t>
-            </a:r>
-          </a:p>
-        </p:txBody>
-      </p:sp>
-      <p:sp>
-        <p:nvSpPr>
-          <p:cNvPr id="4" name="TextBox 3"/>
-          <p:cNvSpPr txBox="1"/>
-          <p:nvPr/>
-        </p:nvSpPr>
-        <p:spPr>
-          <a:xfrm>
-            <a:off x="731520" y="384048"/>
-            <a:ext cx="7680960" cy="502920"/>
-          </a:xfrm>
-          <a:prstGeom prst="rect">
-            <a:avLst/>
-          </a:prstGeom>
-          <a:noFill/>
-        </p:spPr>
-        <p:txBody>
-          <a:bodyPr wrap="square">
-            <a:spAutoFit/>
-          </a:bodyPr>
-          <a:lstStyle/>
-          <a:p>
-            <a:pPr>
-              <a:defRPr sz="2000" b="1">
-                <a:solidFill>
-                  <a:srgbClr val="FFFFFF"/>
-                </a:solidFill>
-              </a:defRPr>
-            </a:pPr>
-            <a:r>
-              <a:t>11. Architectural Discussion &amp; Scalability Insights</a:t>
-            </a:r>
-          </a:p>
-        </p:txBody>
-      </p:sp>
-      <p:sp>
-        <p:nvSpPr>
-          <p:cNvPr id="5" name="Rounded Rectangle 4"/>
-          <p:cNvSpPr/>
-          <p:nvPr/>
-        </p:nvSpPr>
-        <p:spPr>
-          <a:xfrm>
-            <a:off x="731520" y="1188720"/>
-            <a:ext cx="7680960" cy="3566160"/>
-          </a:xfrm>
-          <a:prstGeom prst="roundRect">
-            <a:avLst/>
-          </a:prstGeom>
-          <a:solidFill>
-            <a:srgbClr val="FFFFFF"/>
-          </a:solidFill>
-          <a:ln>
-            <a:solidFill>
-              <a:srgbClr val="DCE0E6"/>
-            </a:solidFill>
-          </a:ln>
-        </p:spPr>
-        <p:style>
-          <a:lnRef idx="1">
-            <a:schemeClr val="accent1"/>
-          </a:lnRef>
-          <a:fillRef idx="3">
-            <a:schemeClr val="accent1"/>
-          </a:fillRef>
-          <a:effectRef idx="2">
-            <a:schemeClr val="accent1"/>
-          </a:effectRef>
-          <a:fontRef idx="minor">
-            <a:schemeClr val="lt1"/>
-          </a:fontRef>
-        </p:style>
-        <p:txBody>
-          <a:bodyPr rtlCol="0" anchor="ctr"/>
-          <a:lstStyle/>
-          <a:p>
-            <a:pPr algn="ctr"/>
-          </a:p>
-        </p:txBody>
-      </p:sp>
-      <p:sp>
-        <p:nvSpPr>
-          <p:cNvPr id="6" name="TextBox 5"/>
-          <p:cNvSpPr txBox="1"/>
-          <p:nvPr/>
-        </p:nvSpPr>
-        <p:spPr>
-          <a:xfrm>
-            <a:off x="914400" y="1280160"/>
-            <a:ext cx="7315200" cy="3291840"/>
-          </a:xfrm>
-          <a:prstGeom prst="rect">
-            <a:avLst/>
-          </a:prstGeom>
-          <a:noFill/>
-        </p:spPr>
-        <p:txBody>
-          <a:bodyPr wrap="square">
-            <a:spAutoFit/>
-          </a:bodyPr>
-          <a:lstStyle/>
-          <a:p>
-            <a:pPr>
-              <a:spcAft>
-                <a:spcPts val="200"/>
-              </a:spcAft>
-              <a:defRPr sz="1300" b="1">
-                <a:solidFill>
-                  <a:srgbClr val="182B49"/>
-                </a:solidFill>
-              </a:defRPr>
-            </a:pPr>
-            <a:r>
-              <a:t>Shared vs. Distributed Memory Trade-offs</a:t>
-            </a:r>
-          </a:p>
-          <a:p>
-            <a:pPr>
-              <a:spcAft>
-                <a:spcPts val="1000"/>
-              </a:spcAft>
-              <a:defRPr sz="1100">
-                <a:solidFill>
-                  <a:srgbClr val="2D3436"/>
-                </a:solidFill>
-              </a:defRPr>
-            </a:pPr>
-            <a:r>
-              <a:t>OpenMP excels on single-node SMP systems with zero message serialization overhead. MPI provides superior cache isolation through 1D domain decomposition.</a:t>
-            </a:r>
-          </a:p>
-          <a:p>
-            <a:pPr>
-              <a:spcAft>
-                <a:spcPts val="200"/>
-              </a:spcAft>
-              <a:defRPr sz="1300" b="1">
-                <a:solidFill>
-                  <a:srgbClr val="182B49"/>
-                </a:solidFill>
-              </a:defRPr>
-            </a:pPr>
-            <a:r>
-              <a:t>Collective Communication Latency</a:t>
-            </a:r>
-          </a:p>
-          <a:p>
-            <a:pPr>
-              <a:spcAft>
-                <a:spcPts val="1000"/>
-              </a:spcAft>
-              <a:defRPr sz="1100">
-                <a:solidFill>
-                  <a:srgbClr val="2D3436"/>
-                </a:solidFill>
-              </a:defRPr>
-            </a:pPr>
-            <a:r>
-              <a:t>MPI requires explicit synchronization (MPI_Bcast, MPI_Reduce) using binomial spanning trees with O(log P) complexity to distribute and reduce variables.</a:t>
-            </a:r>
-          </a:p>
-          <a:p>
-            <a:pPr>
-              <a:spcAft>
-                <a:spcPts val="200"/>
-              </a:spcAft>
-              <a:defRPr sz="1300" b="1">
-                <a:solidFill>
-                  <a:srgbClr val="182B49"/>
-                </a:solidFill>
-              </a:defRPr>
-            </a:pPr>
-            <a:r>
-              <a:t>Memory Bus &amp; Roofline Limits</a:t>
-            </a:r>
-          </a:p>
-          <a:p>
-            <a:pPr>
-              <a:spcAft>
-                <a:spcPts val="1000"/>
-              </a:spcAft>
-              <a:defRPr sz="1100">
-                <a:solidFill>
-                  <a:srgbClr val="2D3436"/>
-                </a:solidFill>
-              </a:defRPr>
-            </a:pPr>
-            <a:r>
-              <a:t>Speedup saturation beyond 8 cores is governed by memory bandwidth limits on the host memory controller when processing contiguous floating-point streams.</a:t>
-            </a:r>
-          </a:p>
-          <a:p>
-            <a:pPr>
-              <a:spcAft>
-                <a:spcPts val="200"/>
-              </a:spcAft>
-              <a:defRPr sz="1300" b="1">
-                <a:solidFill>
-                  <a:srgbClr val="182B49"/>
-                </a:solidFill>
-              </a:defRPr>
-            </a:pPr>
-            <a:r>
-              <a:t>Heterogeneous Core Scaling</a:t>
-            </a:r>
-          </a:p>
-          <a:p>
-            <a:pPr>
-              <a:spcAft>
-                <a:spcPts val="1000"/>
-              </a:spcAft>
-              <a:defRPr sz="1100">
-                <a:solidFill>
-                  <a:srgbClr val="2D3436"/>
-                </a:solidFill>
-              </a:defRPr>
-            </a:pPr>
-            <a:r>
-              <a:t>Intel hybrid architectures (P-cores vs E-cores) and hyperthreading (SMT) deliver diminishing efficiency returns compared to dedicated physical execution units.</a:t>
-            </a:r>
-          </a:p>
-        </p:txBody>
-      </p:sp>
-    </p:spTree>
-  </p:cSld>
-  <p:clrMapOvr>
-    <a:masterClrMapping/>
-  </p:clrMapOvr>
-</p:sld>
-</file>
-
 <file path=ppt/slides/slide13.xml><?xml version="1.0" encoding="utf-8"?>
 <p:sld xmlns:a="http://schemas.openxmlformats.org/drawingml/2006/main" xmlns:p="http://schemas.openxmlformats.org/presentationml/2006/main" xmlns:r="http://schemas.openxmlformats.org/officeDocument/2006/relationships">
   <p:cSld>
@@ -5205,7 +5200,336 @@
               </a:defRPr>
             </a:pPr>
             <a:r>
-              <a:t>12. Conclusion &amp; Future Scope</a:t>
+              <a:t>12. Architectural Discussion &amp; Scalability Insights</a:t>
+            </a:r>
+          </a:p>
+        </p:txBody>
+      </p:sp>
+      <p:sp>
+        <p:nvSpPr>
+          <p:cNvPr id="5" name="Rounded Rectangle 4"/>
+          <p:cNvSpPr/>
+          <p:nvPr/>
+        </p:nvSpPr>
+        <p:spPr>
+          <a:xfrm>
+            <a:off x="731520" y="1188720"/>
+            <a:ext cx="7680960" cy="3566160"/>
+          </a:xfrm>
+          <a:prstGeom prst="roundRect">
+            <a:avLst/>
+          </a:prstGeom>
+          <a:solidFill>
+            <a:srgbClr val="FFFFFF"/>
+          </a:solidFill>
+          <a:ln>
+            <a:solidFill>
+              <a:srgbClr val="DCE0E6"/>
+            </a:solidFill>
+          </a:ln>
+        </p:spPr>
+        <p:style>
+          <a:lnRef idx="1">
+            <a:schemeClr val="accent1"/>
+          </a:lnRef>
+          <a:fillRef idx="3">
+            <a:schemeClr val="accent1"/>
+          </a:fillRef>
+          <a:effectRef idx="2">
+            <a:schemeClr val="accent1"/>
+          </a:effectRef>
+          <a:fontRef idx="minor">
+            <a:schemeClr val="lt1"/>
+          </a:fontRef>
+        </p:style>
+        <p:txBody>
+          <a:bodyPr rtlCol="0" anchor="ctr"/>
+          <a:lstStyle/>
+          <a:p>
+            <a:pPr algn="ctr"/>
+          </a:p>
+        </p:txBody>
+      </p:sp>
+      <p:sp>
+        <p:nvSpPr>
+          <p:cNvPr id="6" name="TextBox 5"/>
+          <p:cNvSpPr txBox="1"/>
+          <p:nvPr/>
+        </p:nvSpPr>
+        <p:spPr>
+          <a:xfrm>
+            <a:off x="914400" y="1280160"/>
+            <a:ext cx="7315200" cy="3291840"/>
+          </a:xfrm>
+          <a:prstGeom prst="rect">
+            <a:avLst/>
+          </a:prstGeom>
+          <a:noFill/>
+        </p:spPr>
+        <p:txBody>
+          <a:bodyPr wrap="square">
+            <a:spAutoFit/>
+          </a:bodyPr>
+          <a:lstStyle/>
+          <a:p>
+            <a:pPr>
+              <a:spcAft>
+                <a:spcPts val="200"/>
+              </a:spcAft>
+              <a:defRPr sz="1300" b="1">
+                <a:solidFill>
+                  <a:srgbClr val="182B49"/>
+                </a:solidFill>
+              </a:defRPr>
+            </a:pPr>
+            <a:r>
+              <a:t>Shared vs. Distributed Memory Trade-offs</a:t>
+            </a:r>
+          </a:p>
+          <a:p>
+            <a:pPr>
+              <a:spcAft>
+                <a:spcPts val="1000"/>
+              </a:spcAft>
+              <a:defRPr sz="1100">
+                <a:solidFill>
+                  <a:srgbClr val="2D3436"/>
+                </a:solidFill>
+              </a:defRPr>
+            </a:pPr>
+            <a:r>
+              <a:t>OpenMP excels on single-node SMP systems with zero message serialization overhead. MPI provides superior cache isolation through 1D domain decomposition.</a:t>
+            </a:r>
+          </a:p>
+          <a:p>
+            <a:pPr>
+              <a:spcAft>
+                <a:spcPts val="200"/>
+              </a:spcAft>
+              <a:defRPr sz="1300" b="1">
+                <a:solidFill>
+                  <a:srgbClr val="182B49"/>
+                </a:solidFill>
+              </a:defRPr>
+            </a:pPr>
+            <a:r>
+              <a:t>Collective Communication Latency</a:t>
+            </a:r>
+          </a:p>
+          <a:p>
+            <a:pPr>
+              <a:spcAft>
+                <a:spcPts val="1000"/>
+              </a:spcAft>
+              <a:defRPr sz="1100">
+                <a:solidFill>
+                  <a:srgbClr val="2D3436"/>
+                </a:solidFill>
+              </a:defRPr>
+            </a:pPr>
+            <a:r>
+              <a:t>MPI requires explicit synchronization (MPI_Bcast, MPI_Reduce) using binomial spanning trees with O(log P) complexity to distribute and reduce variables.</a:t>
+            </a:r>
+          </a:p>
+          <a:p>
+            <a:pPr>
+              <a:spcAft>
+                <a:spcPts val="200"/>
+              </a:spcAft>
+              <a:defRPr sz="1300" b="1">
+                <a:solidFill>
+                  <a:srgbClr val="182B49"/>
+                </a:solidFill>
+              </a:defRPr>
+            </a:pPr>
+            <a:r>
+              <a:t>Memory Bus &amp; Roofline Limits</a:t>
+            </a:r>
+          </a:p>
+          <a:p>
+            <a:pPr>
+              <a:spcAft>
+                <a:spcPts val="1000"/>
+              </a:spcAft>
+              <a:defRPr sz="1100">
+                <a:solidFill>
+                  <a:srgbClr val="2D3436"/>
+                </a:solidFill>
+              </a:defRPr>
+            </a:pPr>
+            <a:r>
+              <a:t>Speedup saturation beyond 8 cores is governed by memory bandwidth limits on the host memory controller when processing contiguous floating-point streams.</a:t>
+            </a:r>
+          </a:p>
+          <a:p>
+            <a:pPr>
+              <a:spcAft>
+                <a:spcPts val="200"/>
+              </a:spcAft>
+              <a:defRPr sz="1300" b="1">
+                <a:solidFill>
+                  <a:srgbClr val="182B49"/>
+                </a:solidFill>
+              </a:defRPr>
+            </a:pPr>
+            <a:r>
+              <a:t>Heterogeneous Core Scaling</a:t>
+            </a:r>
+          </a:p>
+          <a:p>
+            <a:pPr>
+              <a:spcAft>
+                <a:spcPts val="1000"/>
+              </a:spcAft>
+              <a:defRPr sz="1100">
+                <a:solidFill>
+                  <a:srgbClr val="2D3436"/>
+                </a:solidFill>
+              </a:defRPr>
+            </a:pPr>
+            <a:r>
+              <a:t>Intel hybrid architectures (P-cores vs E-cores) and hyperthreading (SMT) deliver diminishing efficiency returns compared to dedicated physical execution units.</a:t>
+            </a:r>
+          </a:p>
+        </p:txBody>
+      </p:sp>
+    </p:spTree>
+  </p:cSld>
+  <p:clrMapOvr>
+    <a:masterClrMapping/>
+  </p:clrMapOvr>
+</p:sld>
+</file>
+
+<file path=ppt/slides/slide14.xml><?xml version="1.0" encoding="utf-8"?>
+<p:sld xmlns:a="http://schemas.openxmlformats.org/drawingml/2006/main" xmlns:p="http://schemas.openxmlformats.org/presentationml/2006/main" xmlns:r="http://schemas.openxmlformats.org/officeDocument/2006/relationships">
+  <p:cSld>
+    <p:bg>
+      <p:bgPr>
+        <a:solidFill>
+          <a:srgbClr val="F5F7FA"/>
+        </a:solidFill>
+        <a:effectLst/>
+      </p:bgPr>
+    </p:bg>
+    <p:spTree>
+      <p:nvGrpSpPr>
+        <p:cNvPr id="1" name=""/>
+        <p:cNvGrpSpPr/>
+        <p:nvPr/>
+      </p:nvGrpSpPr>
+      <p:grpSpPr/>
+      <p:sp>
+        <p:nvSpPr>
+          <p:cNvPr id="2" name="Rectangle 1"/>
+          <p:cNvSpPr/>
+          <p:nvPr/>
+        </p:nvSpPr>
+        <p:spPr>
+          <a:xfrm>
+            <a:off x="0" y="0"/>
+            <a:ext cx="9144000" cy="1005840"/>
+          </a:xfrm>
+          <a:prstGeom prst="rect">
+            <a:avLst/>
+          </a:prstGeom>
+          <a:solidFill>
+            <a:srgbClr val="182B49"/>
+          </a:solidFill>
+          <a:ln>
+            <a:solidFill>
+              <a:srgbClr val="182B49"/>
+            </a:solidFill>
+          </a:ln>
+        </p:spPr>
+        <p:style>
+          <a:lnRef idx="1">
+            <a:schemeClr val="accent1"/>
+          </a:lnRef>
+          <a:fillRef idx="3">
+            <a:schemeClr val="accent1"/>
+          </a:fillRef>
+          <a:effectRef idx="2">
+            <a:schemeClr val="accent1"/>
+          </a:effectRef>
+          <a:fontRef idx="minor">
+            <a:schemeClr val="lt1"/>
+          </a:fontRef>
+        </p:style>
+        <p:txBody>
+          <a:bodyPr rtlCol="0" anchor="ctr"/>
+          <a:lstStyle/>
+          <a:p>
+            <a:pPr algn="ctr"/>
+          </a:p>
+        </p:txBody>
+      </p:sp>
+      <p:sp>
+        <p:nvSpPr>
+          <p:cNvPr id="3" name="TextBox 2"/>
+          <p:cNvSpPr txBox="1"/>
+          <p:nvPr/>
+        </p:nvSpPr>
+        <p:spPr>
+          <a:xfrm>
+            <a:off x="731520" y="109728"/>
+            <a:ext cx="7680960" cy="274320"/>
+          </a:xfrm>
+          <a:prstGeom prst="rect">
+            <a:avLst/>
+          </a:prstGeom>
+          <a:noFill/>
+        </p:spPr>
+        <p:txBody>
+          <a:bodyPr wrap="square">
+            <a:spAutoFit/>
+          </a:bodyPr>
+          <a:lstStyle/>
+          <a:p>
+            <a:pPr>
+              <a:defRPr sz="1000" b="1">
+                <a:solidFill>
+                  <a:srgbClr val="107C82"/>
+                </a:solidFill>
+              </a:defRPr>
+            </a:pPr>
+            <a:r>
+              <a:t>PARALLEL COMPUTING MINI-PROJECT | TOPIC #9</a:t>
+            </a:r>
+          </a:p>
+        </p:txBody>
+      </p:sp>
+      <p:sp>
+        <p:nvSpPr>
+          <p:cNvPr id="4" name="TextBox 3"/>
+          <p:cNvSpPr txBox="1"/>
+          <p:nvPr/>
+        </p:nvSpPr>
+        <p:spPr>
+          <a:xfrm>
+            <a:off x="731520" y="384048"/>
+            <a:ext cx="7680960" cy="502920"/>
+          </a:xfrm>
+          <a:prstGeom prst="rect">
+            <a:avLst/>
+          </a:prstGeom>
+          <a:noFill/>
+        </p:spPr>
+        <p:txBody>
+          <a:bodyPr wrap="square">
+            <a:spAutoFit/>
+          </a:bodyPr>
+          <a:lstStyle/>
+          <a:p>
+            <a:pPr>
+              <a:defRPr sz="2000" b="1">
+                <a:solidFill>
+                  <a:srgbClr val="FFFFFF"/>
+                </a:solidFill>
+              </a:defRPr>
+            </a:pPr>
+            <a:r>
+              <a:t>13. Conclusion &amp; Future Scope</a:t>
             </a:r>
           </a:p>
         </p:txBody>

</xml_diff>